<commit_message>
Slides: question titles at 92 px on sd-01-046 and sd-01-047, re-export badged PPTX
Co-Authored-By: Claude Opus 5.5 <noreply@anthropic.com>
Claude-Session: https://claude.ai/code/session_01PmqNRWe4NoiAuhPfHYj9Qq
</commit_message>
<xml_diff>
--- a/system-design-101/vi/lessons/sd-01-046/slides/sd-01-046.pptx
+++ b/system-design-101/vi/lessons/sd-01-046/slides/sd-01-046.pptx
@@ -9298,17 +9298,17 @@
           <a:ln/>
         </p:spPr>
         <p:txBody>
-          <a:bodyPr wrap="square" lIns="0" tIns="50292" rIns="0" bIns="-50292" rtlCol="0" anchor="ctr"/>
+          <a:bodyPr wrap="square" lIns="0" tIns="52578" rIns="0" bIns="-52578" rtlCol="0" anchor="ctr"/>
           <a:lstStyle/>
           <a:p>
             <a:pPr algn="l" indent="0" marL="0">
               <a:lnSpc>
-                <a:spcPts val="7128"/>
+                <a:spcPts val="7452"/>
               </a:lnSpc>
               <a:buNone/>
             </a:pPr>
             <a:r>
-              <a:rPr lang="en-US" sz="6600" dirty="0" spc="-1" kern="0">
+              <a:rPr lang="en-US" sz="6900" dirty="0" spc="0" kern="0">
                 <a:solidFill>
                   <a:srgbClr val="14161C"/>
                 </a:solidFill>
@@ -9319,7 +9319,7 @@
               <a:t>Không.</a:t>
             </a:r>
             <a:r>
-              <a:rPr lang="en-US" sz="6600" dirty="0" spc="2" kern="0">
+              <a:rPr lang="en-US" sz="6900" dirty="0" spc="1" kern="0">
                 <a:solidFill>
                   <a:srgbClr val="14161C"/>
                 </a:solidFill>
@@ -9330,7 +9330,7 @@
               <a:t> Số</a:t>
             </a:r>
             <a:r>
-              <a:rPr lang="en-US" sz="6600" dirty="0" spc="-68" kern="0">
+              <a:rPr lang="en-US" sz="6900" dirty="0" spc="-72" kern="0">
                 <a:solidFill>
                   <a:srgbClr val="14161C"/>
                 </a:solidFill>
@@ -9341,7 +9341,7 @@
               <a:t> lượt</a:t>
             </a:r>
             <a:r>
-              <a:rPr lang="en-US" sz="6600" dirty="0" spc="-40" kern="0">
+              <a:rPr lang="en-US" sz="6900" dirty="0" spc="-41" kern="0">
                 <a:solidFill>
                   <a:srgbClr val="14161C"/>
                 </a:solidFill>
@@ -9352,7 +9352,7 @@
               <a:t> gọi</a:t>
             </a:r>
             <a:r>
-              <a:rPr lang="en-US" sz="6600" dirty="0" spc="-45" kern="0">
+              <a:rPr lang="en-US" sz="6900" dirty="0" spc="-48" kern="0">
                 <a:solidFill>
                   <a:srgbClr val="14161C"/>
                 </a:solidFill>
@@ -9363,7 +9363,7 @@
               <a:t> chưa</a:t>
             </a:r>
             <a:r>
-              <a:rPr lang="en-US" sz="6600" dirty="0" spc="-1" kern="0">
+              <a:rPr lang="en-US" sz="6900" dirty="0" spc="2" kern="0">
                 <a:solidFill>
                   <a:srgbClr val="14161C"/>
                 </a:solidFill>
@@ -9374,7 +9374,7 @@
               <a:t> nói</a:t>
             </a:r>
             <a:r>
-              <a:rPr lang="en-US" sz="6600" dirty="0" spc="-25" kern="0">
+              <a:rPr lang="en-US" sz="6900" dirty="0" spc="-29" kern="0">
                 <a:solidFill>
                   <a:srgbClr val="14161C"/>
                 </a:solidFill>
@@ -9385,7 +9385,7 @@
               <a:t> tốc</a:t>
             </a:r>
             <a:r>
-              <a:rPr lang="en-US" sz="6600" dirty="0" spc="-4" kern="0">
+              <a:rPr lang="en-US" sz="6900" dirty="0" spc="-7" kern="0">
                 <a:solidFill>
                   <a:srgbClr val="14161C"/>
                 </a:solidFill>
@@ -9395,7 +9395,7 @@
               </a:rPr>
               <a:t> độ.</a:t>
             </a:r>
-            <a:endParaRPr lang="en-US" sz="6600" dirty="0"/>
+            <a:endParaRPr lang="en-US" sz="6900" dirty="0"/>
           </a:p>
         </p:txBody>
       </p:sp>

</xml_diff>

<commit_message>
Slides: code labels in Be Vietnam Pro on sd-01-046..048, re-export badged PPTX
Co-Authored-By: Claude Opus 5.5 <noreply@anthropic.com>
Claude-Session: https://claude.ai/code/session_01PmqNRWe4NoiAuhPfHYj9Qq
</commit_message>
<xml_diff>
--- a/system-design-101/vi/lessons/sd-01-046/slides/sd-01-046.pptx
+++ b/system-design-101/vi/lessons/sd-01-046/slides/sd-01-046.pptx
@@ -31,12 +31,8 @@
       <p:regular r:id="rId17"/>
     </p:embeddedFont>
     <p:embeddedFont>
-      <p:font typeface="Roboto Mono"/>
-      <p:bold r:id="rId19"/>
-    </p:embeddedFont>
-    <p:embeddedFont>
       <p:font typeface="Be Vietnam Pro SemiBold"/>
-      <p:regular r:id="rId20"/>
+      <p:regular r:id="rId19"/>
     </p:embeddedFont>
   </p:embeddedFontLst>
   <p:defaultTextStyle>
@@ -2182,7 +2178,7 @@
           <a:ln/>
         </p:spPr>
         <p:txBody>
-          <a:bodyPr wrap="square" lIns="0" tIns="12445" rIns="0" bIns="-12445" rtlCol="0" anchor="t"/>
+          <a:bodyPr wrap="square" lIns="0" tIns="5667" rIns="0" bIns="-5667" rtlCol="0" anchor="t"/>
           <a:lstStyle/>
           <a:p>
             <a:pPr algn="l" indent="0" marL="0">
@@ -2192,15 +2188,26 @@
               <a:buNone/>
             </a:pPr>
             <a:r>
-              <a:rPr lang="en-US" sz="2550" b="1" dirty="0" spc="5" kern="0">
+              <a:rPr lang="en-US" sz="2550" b="1" dirty="0" spc="0" kern="0">
                 <a:solidFill>
                   <a:srgbClr val="F3EEE3"/>
                 </a:solidFill>
-                <a:latin typeface="Roboto Mono" pitchFamily="34" charset="0"/>
-                <a:ea typeface="Roboto Mono" pitchFamily="34" charset="-122"/>
-                <a:cs typeface="Roboto Mono" pitchFamily="34" charset="-120"/>
-              </a:rPr>
-              <a:t>GET /books/7?fields=title,author</a:t>
+                <a:latin typeface="Be Vietnam Pro" pitchFamily="34" charset="0"/>
+                <a:ea typeface="Be Vietnam Pro" pitchFamily="34" charset="-122"/>
+                <a:cs typeface="Be Vietnam Pro" pitchFamily="34" charset="-120"/>
+              </a:rPr>
+              <a:t>GET</a:t>
+            </a:r>
+            <a:r>
+              <a:rPr lang="en-US" sz="2550" b="1" dirty="0" spc="1" kern="0">
+                <a:solidFill>
+                  <a:srgbClr val="F3EEE3"/>
+                </a:solidFill>
+                <a:latin typeface="Be Vietnam Pro" pitchFamily="34" charset="0"/>
+                <a:ea typeface="Be Vietnam Pro" pitchFamily="34" charset="-122"/>
+                <a:cs typeface="Be Vietnam Pro" pitchFamily="34" charset="-120"/>
+              </a:rPr>
+              <a:t> /books/7?fields=title,author</a:t>
             </a:r>
             <a:endParaRPr lang="en-US" sz="2550" dirty="0"/>
           </a:p>
@@ -2301,7 +2308,7 @@
           <a:ln/>
         </p:spPr>
         <p:txBody>
-          <a:bodyPr wrap="square" lIns="0" tIns="12445" rIns="0" bIns="-12445" rtlCol="0" anchor="t"/>
+          <a:bodyPr wrap="square" lIns="0" tIns="5667" rIns="0" bIns="-5667" rtlCol="0" anchor="t"/>
           <a:lstStyle/>
           <a:p>
             <a:pPr algn="l" indent="0" marL="0">
@@ -2311,46 +2318,57 @@
               <a:buNone/>
             </a:pPr>
             <a:r>
-              <a:rPr lang="en-US" sz="2550" b="1" dirty="0" spc="5" kern="0">
+              <a:rPr lang="en-US" sz="2550" b="1" dirty="0" spc="-1" kern="0">
                 <a:solidFill>
                   <a:srgbClr val="F3EEE3"/>
                 </a:solidFill>
-                <a:latin typeface="Roboto Mono" pitchFamily="34" charset="0"/>
-                <a:ea typeface="Roboto Mono" pitchFamily="34" charset="-122"/>
-                <a:cs typeface="Roboto Mono" pitchFamily="34" charset="-120"/>
-              </a:rPr>
-              <a:t>title author</a:t>
-            </a:r>
-            <a:r>
-              <a:rPr lang="en-US" sz="2550" b="1" dirty="0" spc="7" kern="0">
+                <a:latin typeface="Be Vietnam Pro" pitchFamily="34" charset="0"/>
+                <a:ea typeface="Be Vietnam Pro" pitchFamily="34" charset="-122"/>
+                <a:cs typeface="Be Vietnam Pro" pitchFamily="34" charset="-120"/>
+              </a:rPr>
+              <a:t>title</a:t>
+            </a:r>
+            <a:r>
+              <a:rPr lang="en-US" sz="2550" b="1" dirty="0" spc="1" kern="0">
                 <a:solidFill>
                   <a:srgbClr val="F3EEE3"/>
                 </a:solidFill>
-                <a:latin typeface="Roboto Mono" pitchFamily="34" charset="0"/>
-                <a:ea typeface="Roboto Mono" pitchFamily="34" charset="-122"/>
-                <a:cs typeface="Roboto Mono" pitchFamily="34" charset="-120"/>
+                <a:latin typeface="Be Vietnam Pro" pitchFamily="34" charset="0"/>
+                <a:ea typeface="Be Vietnam Pro" pitchFamily="34" charset="-122"/>
+                <a:cs typeface="Be Vietnam Pro" pitchFamily="34" charset="-120"/>
+              </a:rPr>
+              <a:t> author</a:t>
+            </a:r>
+            <a:r>
+              <a:rPr lang="en-US" sz="2550" b="1" dirty="0" spc="-2" kern="0">
+                <a:solidFill>
+                  <a:srgbClr val="F3EEE3"/>
+                </a:solidFill>
+                <a:latin typeface="Be Vietnam Pro" pitchFamily="34" charset="0"/>
+                <a:ea typeface="Be Vietnam Pro" pitchFamily="34" charset="-122"/>
+                <a:cs typeface="Be Vietnam Pro" pitchFamily="34" charset="-120"/>
               </a:rPr>
               <a:t> {</a:t>
             </a:r>
             <a:r>
-              <a:rPr lang="en-US" sz="2550" b="1" dirty="0" spc="5" kern="0">
+              <a:rPr lang="en-US" sz="2550" b="1" dirty="0" spc="-5" kern="0">
                 <a:solidFill>
                   <a:srgbClr val="F3EEE3"/>
                 </a:solidFill>
-                <a:latin typeface="Roboto Mono" pitchFamily="34" charset="0"/>
-                <a:ea typeface="Roboto Mono" pitchFamily="34" charset="-122"/>
-                <a:cs typeface="Roboto Mono" pitchFamily="34" charset="-120"/>
+                <a:latin typeface="Be Vietnam Pro" pitchFamily="34" charset="0"/>
+                <a:ea typeface="Be Vietnam Pro" pitchFamily="34" charset="-122"/>
+                <a:cs typeface="Be Vietnam Pro" pitchFamily="34" charset="-120"/>
               </a:rPr>
               <a:t> name</a:t>
             </a:r>
             <a:r>
-              <a:rPr lang="en-US" sz="2550" b="1" dirty="0" spc="6" kern="0">
+              <a:rPr lang="en-US" sz="2550" b="1" dirty="0" spc="0" kern="0">
                 <a:solidFill>
                   <a:srgbClr val="F3EEE3"/>
                 </a:solidFill>
-                <a:latin typeface="Roboto Mono" pitchFamily="34" charset="0"/>
-                <a:ea typeface="Roboto Mono" pitchFamily="34" charset="-122"/>
-                <a:cs typeface="Roboto Mono" pitchFamily="34" charset="-120"/>
+                <a:latin typeface="Be Vietnam Pro" pitchFamily="34" charset="0"/>
+                <a:ea typeface="Be Vietnam Pro" pitchFamily="34" charset="-122"/>
+                <a:cs typeface="Be Vietnam Pro" pitchFamily="34" charset="-120"/>
               </a:rPr>
               <a:t> }</a:t>
             </a:r>
@@ -3955,15 +3973,26 @@
               <a:buNone/>
             </a:pPr>
             <a:r>
-              <a:rPr lang="en-US" sz="3000" b="1" dirty="0" kern="0">
+              <a:rPr lang="en-US" sz="3000" b="1" dirty="0" spc="-3" kern="0">
                 <a:solidFill>
                   <a:srgbClr val="14161C"/>
                 </a:solidFill>
-                <a:latin typeface="Roboto Mono" pitchFamily="34" charset="0"/>
-                <a:ea typeface="Roboto Mono" pitchFamily="34" charset="-122"/>
-                <a:cs typeface="Roboto Mono" pitchFamily="34" charset="-120"/>
-              </a:rPr>
-              <a:t>GET /books/7?fields=title,author</a:t>
+                <a:latin typeface="Be Vietnam Pro" pitchFamily="34" charset="0"/>
+                <a:ea typeface="Be Vietnam Pro" pitchFamily="34" charset="-122"/>
+                <a:cs typeface="Be Vietnam Pro" pitchFamily="34" charset="-120"/>
+              </a:rPr>
+              <a:t>GET</a:t>
+            </a:r>
+            <a:r>
+              <a:rPr lang="en-US" sz="3000" b="1" dirty="0" spc="0" kern="0">
+                <a:solidFill>
+                  <a:srgbClr val="14161C"/>
+                </a:solidFill>
+                <a:latin typeface="Be Vietnam Pro" pitchFamily="34" charset="0"/>
+                <a:ea typeface="Be Vietnam Pro" pitchFamily="34" charset="-122"/>
+                <a:cs typeface="Be Vietnam Pro" pitchFamily="34" charset="-120"/>
+              </a:rPr>
+              <a:t> /books/7?fields=title,author</a:t>
             </a:r>
             <a:endParaRPr lang="en-US" sz="3000" dirty="0"/>
           </a:p>
@@ -5162,37 +5191,48 @@
               <a:buNone/>
             </a:pPr>
             <a:r>
-              <a:rPr lang="en-US" sz="3900" b="1" dirty="0" spc="3" kern="0">
+              <a:rPr lang="en-US" sz="3900" b="1" dirty="0" spc="-6" kern="0">
                 <a:solidFill>
                   <a:srgbClr val="F3EEE3"/>
                 </a:solidFill>
-                <a:latin typeface="Roboto Mono" pitchFamily="34" charset="0"/>
-                <a:ea typeface="Roboto Mono" pitchFamily="34" charset="-122"/>
-                <a:cs typeface="Roboto Mono" pitchFamily="34" charset="-120"/>
-              </a:rPr>
-              <a:t>title  author</a:t>
-            </a:r>
-            <a:r>
-              <a:rPr lang="en-US" sz="3900" b="1" dirty="0" spc="2" kern="0">
+                <a:latin typeface="Be Vietnam Pro" pitchFamily="34" charset="0"/>
+                <a:ea typeface="Be Vietnam Pro" pitchFamily="34" charset="-122"/>
+                <a:cs typeface="Be Vietnam Pro" pitchFamily="34" charset="-120"/>
+              </a:rPr>
+              <a:t>title</a:t>
+            </a:r>
+            <a:r>
+              <a:rPr lang="en-US" sz="3900" b="1" dirty="0" spc="-1" kern="0">
                 <a:solidFill>
                   <a:srgbClr val="F3EEE3"/>
                 </a:solidFill>
-                <a:latin typeface="Roboto Mono" pitchFamily="34" charset="0"/>
-                <a:ea typeface="Roboto Mono" pitchFamily="34" charset="-122"/>
-                <a:cs typeface="Roboto Mono" pitchFamily="34" charset="-120"/>
-              </a:rPr>
-              <a:t> {</a:t>
-            </a:r>
-            <a:r>
-              <a:rPr lang="en-US" sz="3900" b="1" dirty="0" spc="3" kern="0">
+                <a:latin typeface="Be Vietnam Pro" pitchFamily="34" charset="0"/>
+                <a:ea typeface="Be Vietnam Pro" pitchFamily="34" charset="-122"/>
+                <a:cs typeface="Be Vietnam Pro" pitchFamily="34" charset="-120"/>
+              </a:rPr>
+              <a:t>  author {</a:t>
+            </a:r>
+            <a:r>
+              <a:rPr lang="en-US" sz="3900" b="1" dirty="0" spc="-10" kern="0">
                 <a:solidFill>
                   <a:srgbClr val="F3EEE3"/>
                 </a:solidFill>
-                <a:latin typeface="Roboto Mono" pitchFamily="34" charset="0"/>
-                <a:ea typeface="Roboto Mono" pitchFamily="34" charset="-122"/>
-                <a:cs typeface="Roboto Mono" pitchFamily="34" charset="-120"/>
-              </a:rPr>
-              <a:t> name }</a:t>
+                <a:latin typeface="Be Vietnam Pro" pitchFamily="34" charset="0"/>
+                <a:ea typeface="Be Vietnam Pro" pitchFamily="34" charset="-122"/>
+                <a:cs typeface="Be Vietnam Pro" pitchFamily="34" charset="-120"/>
+              </a:rPr>
+              <a:t> name</a:t>
+            </a:r>
+            <a:r>
+              <a:rPr lang="en-US" sz="3900" b="1" dirty="0" spc="-2" kern="0">
+                <a:solidFill>
+                  <a:srgbClr val="F3EEE3"/>
+                </a:solidFill>
+                <a:latin typeface="Be Vietnam Pro" pitchFamily="34" charset="0"/>
+                <a:ea typeface="Be Vietnam Pro" pitchFamily="34" charset="-122"/>
+                <a:cs typeface="Be Vietnam Pro" pitchFamily="34" charset="-120"/>
+              </a:rPr>
+              <a:t> }</a:t>
             </a:r>
             <a:endParaRPr lang="en-US" sz="3900" dirty="0"/>
           </a:p>

</xml_diff>